<commit_message>
Move diagram/wireframe annotations into PowerPoint as native text
Strip the baked-in callouts from the journey and the three depth
wireframes; the generator now places them (and the journey's band text)
as native PPT cards + leaders + ring markers, mapped from each diagram's
own SVG coordinates so the layout is unchanged. Annotation text is now
editable in PowerPoint.

Co-Authored-By: Claude Opus 4.8 <noreply@anthropic.com>
Claude-Session: https://claude.ai/code/session_019X1v8XUrUr7FASrTikBJ9b
</commit_message>
<xml_diff>
--- a/presentation/adafsa-redesign-draft.pptx
+++ b/presentation/adafsa-redesign-draft.pptx
@@ -2209,7 +2209,7 @@
           <a:p>
             <a:pPr algn="l" indent="0" marL="0">
               <a:lnSpc>
-                <a:spcPct val="105000"/>
+                <a:spcPct val="104000"/>
               </a:lnSpc>
               <a:buNone/>
             </a:pPr>
@@ -2325,7 +2325,7 @@
           <a:p>
             <a:pPr algn="l" indent="0" marL="0">
               <a:lnSpc>
-                <a:spcPct val="105000"/>
+                <a:spcPct val="104000"/>
               </a:lnSpc>
               <a:buNone/>
             </a:pPr>
@@ -2441,7 +2441,7 @@
           <a:p>
             <a:pPr algn="ctr" indent="0" marL="0">
               <a:lnSpc>
-                <a:spcPct val="105000"/>
+                <a:spcPct val="104000"/>
               </a:lnSpc>
               <a:buNone/>
             </a:pPr>
@@ -2555,6 +2555,470 @@
           </a:prstGeom>
         </p:spPr>
       </p:pic>
+      <p:sp>
+        <p:nvSpPr>
+          <p:cNvPr id="4" name="Shape 1"/>
+          <p:cNvSpPr/>
+          <p:nvPr/>
+        </p:nvSpPr>
+        <p:spPr>
+          <a:xfrm flipH="1">
+            <a:off x="3857041" y="1632052"/>
+            <a:ext cx="211531" cy="1525168"/>
+          </a:xfrm>
+          <a:prstGeom prst="line">
+            <a:avLst/>
+          </a:prstGeom>
+          <a:noFill/>
+          <a:ln w="12700">
+            <a:solidFill>
+              <a:srgbClr val="AEB4BC"/>
+            </a:solidFill>
+            <a:prstDash val="solid"/>
+          </a:ln>
+        </p:spPr>
+      </p:sp>
+      <p:sp>
+        <p:nvSpPr>
+          <p:cNvPr id="5" name="Shape 2"/>
+          <p:cNvSpPr/>
+          <p:nvPr/>
+        </p:nvSpPr>
+        <p:spPr>
+          <a:xfrm>
+            <a:off x="3793033" y="3093212"/>
+            <a:ext cx="128016" cy="128016"/>
+          </a:xfrm>
+          <a:prstGeom prst="ellipse">
+            <a:avLst/>
+          </a:prstGeom>
+          <a:solidFill>
+            <a:srgbClr val="166534"/>
+          </a:solidFill>
+          <a:ln/>
+        </p:spPr>
+      </p:sp>
+      <p:sp>
+        <p:nvSpPr>
+          <p:cNvPr id="6" name="Shape 3"/>
+          <p:cNvSpPr/>
+          <p:nvPr/>
+        </p:nvSpPr>
+        <p:spPr>
+          <a:xfrm>
+            <a:off x="3831438" y="3131617"/>
+            <a:ext cx="51206" cy="51206"/>
+          </a:xfrm>
+          <a:prstGeom prst="ellipse">
+            <a:avLst/>
+          </a:prstGeom>
+          <a:solidFill>
+            <a:srgbClr val="FFFFFF"/>
+          </a:solidFill>
+          <a:ln/>
+        </p:spPr>
+      </p:sp>
+      <p:sp>
+        <p:nvSpPr>
+          <p:cNvPr id="7" name="Text 4"/>
+          <p:cNvSpPr/>
+          <p:nvPr/>
+        </p:nvSpPr>
+        <p:spPr>
+          <a:xfrm>
+            <a:off x="2898140" y="1282446"/>
+            <a:ext cx="2340864" cy="349606"/>
+          </a:xfrm>
+          <a:prstGeom prst="roundRect">
+            <a:avLst>
+              <a:gd name="adj" fmla="val 23540"/>
+            </a:avLst>
+          </a:prstGeom>
+          <a:solidFill>
+            <a:srgbClr val="FFFFFF"/>
+          </a:solidFill>
+          <a:ln/>
+          <a:effectLst>
+            <a:outerShdw sx="100000" sy="100000" kx="0" ky="0" algn="bl" rotWithShape="0" blurRad="114300" dist="38100" dir="5400000">
+              <a:srgbClr val="8A8F98">
+                <a:alpha val="30000"/>
+              </a:srgbClr>
+            </a:outerShdw>
+          </a:effectLst>
+        </p:spPr>
+        <p:txBody>
+          <a:bodyPr wrap="square" lIns="889" tIns="889" rIns="889" bIns="889" rtlCol="0" anchor="ctr"/>
+          <a:lstStyle/>
+          <a:p>
+            <a:pPr algn="l" indent="0" marL="0">
+              <a:lnSpc>
+                <a:spcPct val="104000"/>
+              </a:lnSpc>
+              <a:buNone/>
+            </a:pPr>
+            <a:r>
+              <a:rPr lang="en-US" sz="1050" dirty="0">
+                <a:solidFill>
+                  <a:srgbClr val="1F2937"/>
+                </a:solidFill>
+                <a:latin typeface="Calibri" pitchFamily="34" charset="0"/>
+                <a:ea typeface="Calibri" pitchFamily="34" charset="-122"/>
+                <a:cs typeface="Calibri" pitchFamily="34" charset="-120"/>
+              </a:rPr>
+              <a:t>The farm, highlighted on the map.</a:t>
+            </a:r>
+            <a:endParaRPr lang="en-US" sz="1050" dirty="0"/>
+          </a:p>
+        </p:txBody>
+      </p:sp>
+      <p:sp>
+        <p:nvSpPr>
+          <p:cNvPr id="8" name="Shape 5"/>
+          <p:cNvSpPr/>
+          <p:nvPr/>
+        </p:nvSpPr>
+        <p:spPr>
+          <a:xfrm flipH="1">
+            <a:off x="7151726" y="2354682"/>
+            <a:ext cx="540918" cy="237033"/>
+          </a:xfrm>
+          <a:prstGeom prst="line">
+            <a:avLst/>
+          </a:prstGeom>
+          <a:noFill/>
+          <a:ln w="12700">
+            <a:solidFill>
+              <a:srgbClr val="AEB4BC"/>
+            </a:solidFill>
+            <a:prstDash val="solid"/>
+          </a:ln>
+        </p:spPr>
+      </p:sp>
+      <p:sp>
+        <p:nvSpPr>
+          <p:cNvPr id="9" name="Shape 6"/>
+          <p:cNvSpPr/>
+          <p:nvPr/>
+        </p:nvSpPr>
+        <p:spPr>
+          <a:xfrm>
+            <a:off x="7087718" y="2527706"/>
+            <a:ext cx="128016" cy="128016"/>
+          </a:xfrm>
+          <a:prstGeom prst="ellipse">
+            <a:avLst/>
+          </a:prstGeom>
+          <a:solidFill>
+            <a:srgbClr val="166534"/>
+          </a:solidFill>
+          <a:ln/>
+        </p:spPr>
+      </p:sp>
+      <p:sp>
+        <p:nvSpPr>
+          <p:cNvPr id="10" name="Shape 7"/>
+          <p:cNvSpPr/>
+          <p:nvPr/>
+        </p:nvSpPr>
+        <p:spPr>
+          <a:xfrm>
+            <a:off x="7126122" y="2566111"/>
+            <a:ext cx="51206" cy="51206"/>
+          </a:xfrm>
+          <a:prstGeom prst="ellipse">
+            <a:avLst/>
+          </a:prstGeom>
+          <a:solidFill>
+            <a:srgbClr val="FFFFFF"/>
+          </a:solidFill>
+          <a:ln/>
+        </p:spPr>
+      </p:sp>
+      <p:sp>
+        <p:nvSpPr>
+          <p:cNvPr id="11" name="Text 8"/>
+          <p:cNvSpPr/>
+          <p:nvPr/>
+        </p:nvSpPr>
+        <p:spPr>
+          <a:xfrm>
+            <a:off x="7692644" y="2112264"/>
+            <a:ext cx="2094992" cy="484835"/>
+          </a:xfrm>
+          <a:prstGeom prst="roundRect">
+            <a:avLst>
+              <a:gd name="adj" fmla="val 16974"/>
+            </a:avLst>
+          </a:prstGeom>
+          <a:solidFill>
+            <a:srgbClr val="FFFFFF"/>
+          </a:solidFill>
+          <a:ln/>
+          <a:effectLst>
+            <a:outerShdw sx="100000" sy="100000" kx="0" ky="0" algn="bl" rotWithShape="0" blurRad="114300" dist="38100" dir="5400000">
+              <a:srgbClr val="8A8F98">
+                <a:alpha val="30000"/>
+              </a:srgbClr>
+            </a:outerShdw>
+          </a:effectLst>
+        </p:spPr>
+        <p:txBody>
+          <a:bodyPr wrap="square" lIns="889" tIns="889" rIns="889" bIns="889" rtlCol="0" anchor="ctr"/>
+          <a:lstStyle/>
+          <a:p>
+            <a:pPr algn="l" indent="0" marL="0">
+              <a:lnSpc>
+                <a:spcPct val="104000"/>
+              </a:lnSpc>
+              <a:buNone/>
+            </a:pPr>
+            <a:r>
+              <a:rPr lang="en-US" sz="1050" dirty="0">
+                <a:solidFill>
+                  <a:srgbClr val="1F2937"/>
+                </a:solidFill>
+                <a:latin typeface="Calibri" pitchFamily="34" charset="0"/>
+                <a:ea typeface="Calibri" pitchFamily="34" charset="-122"/>
+                <a:cs typeface="Calibri" pitchFamily="34" charset="-120"/>
+              </a:rPr>
+              <a:t>The system's conclusion, in one sentence.</a:t>
+            </a:r>
+            <a:endParaRPr lang="en-US" sz="1050" dirty="0"/>
+          </a:p>
+        </p:txBody>
+      </p:sp>
+      <p:sp>
+        <p:nvSpPr>
+          <p:cNvPr id="12" name="Shape 9"/>
+          <p:cNvSpPr/>
+          <p:nvPr/>
+        </p:nvSpPr>
+        <p:spPr>
+          <a:xfrm flipH="1">
+            <a:off x="7151726" y="2895600"/>
+            <a:ext cx="540918" cy="839419"/>
+          </a:xfrm>
+          <a:prstGeom prst="line">
+            <a:avLst/>
+          </a:prstGeom>
+          <a:noFill/>
+          <a:ln w="12700">
+            <a:solidFill>
+              <a:srgbClr val="AEB4BC"/>
+            </a:solidFill>
+            <a:prstDash val="solid"/>
+          </a:ln>
+        </p:spPr>
+      </p:sp>
+      <p:sp>
+        <p:nvSpPr>
+          <p:cNvPr id="13" name="Shape 10"/>
+          <p:cNvSpPr/>
+          <p:nvPr/>
+        </p:nvSpPr>
+        <p:spPr>
+          <a:xfrm>
+            <a:off x="7087718" y="3671011"/>
+            <a:ext cx="128016" cy="128016"/>
+          </a:xfrm>
+          <a:prstGeom prst="ellipse">
+            <a:avLst/>
+          </a:prstGeom>
+          <a:solidFill>
+            <a:srgbClr val="166534"/>
+          </a:solidFill>
+          <a:ln/>
+        </p:spPr>
+      </p:sp>
+      <p:sp>
+        <p:nvSpPr>
+          <p:cNvPr id="14" name="Shape 11"/>
+          <p:cNvSpPr/>
+          <p:nvPr/>
+        </p:nvSpPr>
+        <p:spPr>
+          <a:xfrm>
+            <a:off x="7126122" y="3709416"/>
+            <a:ext cx="51206" cy="51206"/>
+          </a:xfrm>
+          <a:prstGeom prst="ellipse">
+            <a:avLst/>
+          </a:prstGeom>
+          <a:solidFill>
+            <a:srgbClr val="FFFFFF"/>
+          </a:solidFill>
+          <a:ln/>
+        </p:spPr>
+      </p:sp>
+      <p:sp>
+        <p:nvSpPr>
+          <p:cNvPr id="15" name="Text 12"/>
+          <p:cNvSpPr/>
+          <p:nvPr/>
+        </p:nvSpPr>
+        <p:spPr>
+          <a:xfrm>
+            <a:off x="7692644" y="2653182"/>
+            <a:ext cx="2094992" cy="484835"/>
+          </a:xfrm>
+          <a:prstGeom prst="roundRect">
+            <a:avLst>
+              <a:gd name="adj" fmla="val 16974"/>
+            </a:avLst>
+          </a:prstGeom>
+          <a:solidFill>
+            <a:srgbClr val="FFFFFF"/>
+          </a:solidFill>
+          <a:ln/>
+          <a:effectLst>
+            <a:outerShdw sx="100000" sy="100000" kx="0" ky="0" algn="bl" rotWithShape="0" blurRad="114300" dist="38100" dir="5400000">
+              <a:srgbClr val="8A8F98">
+                <a:alpha val="30000"/>
+              </a:srgbClr>
+            </a:outerShdw>
+          </a:effectLst>
+        </p:spPr>
+        <p:txBody>
+          <a:bodyPr wrap="square" lIns="889" tIns="889" rIns="889" bIns="889" rtlCol="0" anchor="ctr"/>
+          <a:lstStyle/>
+          <a:p>
+            <a:pPr algn="l" indent="0" marL="0">
+              <a:lnSpc>
+                <a:spcPct val="104000"/>
+              </a:lnSpc>
+              <a:buNone/>
+            </a:pPr>
+            <a:r>
+              <a:rPr lang="en-US" sz="1050" dirty="0">
+                <a:solidFill>
+                  <a:srgbClr val="1F2937"/>
+                </a:solidFill>
+                <a:latin typeface="Calibri" pitchFamily="34" charset="0"/>
+                <a:ea typeface="Calibri" pitchFamily="34" charset="-122"/>
+                <a:cs typeface="Calibri" pitchFamily="34" charset="-120"/>
+              </a:rPr>
+              <a:t>Every module's reading for this one farm.</a:t>
+            </a:r>
+            <a:endParaRPr lang="en-US" sz="1050" dirty="0"/>
+          </a:p>
+        </p:txBody>
+      </p:sp>
+      <p:sp>
+        <p:nvSpPr>
+          <p:cNvPr id="16" name="Shape 13"/>
+          <p:cNvSpPr/>
+          <p:nvPr/>
+        </p:nvSpPr>
+        <p:spPr>
+          <a:xfrm flipH="1">
+            <a:off x="7151726" y="3510280"/>
+            <a:ext cx="540918" cy="1411072"/>
+          </a:xfrm>
+          <a:prstGeom prst="line">
+            <a:avLst/>
+          </a:prstGeom>
+          <a:noFill/>
+          <a:ln w="12700">
+            <a:solidFill>
+              <a:srgbClr val="AEB4BC"/>
+            </a:solidFill>
+            <a:prstDash val="solid"/>
+          </a:ln>
+        </p:spPr>
+      </p:sp>
+      <p:sp>
+        <p:nvSpPr>
+          <p:cNvPr id="17" name="Shape 14"/>
+          <p:cNvSpPr/>
+          <p:nvPr/>
+        </p:nvSpPr>
+        <p:spPr>
+          <a:xfrm>
+            <a:off x="7087718" y="4857344"/>
+            <a:ext cx="128016" cy="128016"/>
+          </a:xfrm>
+          <a:prstGeom prst="ellipse">
+            <a:avLst/>
+          </a:prstGeom>
+          <a:solidFill>
+            <a:srgbClr val="166534"/>
+          </a:solidFill>
+          <a:ln/>
+        </p:spPr>
+      </p:sp>
+      <p:sp>
+        <p:nvSpPr>
+          <p:cNvPr id="18" name="Shape 15"/>
+          <p:cNvSpPr/>
+          <p:nvPr/>
+        </p:nvSpPr>
+        <p:spPr>
+          <a:xfrm>
+            <a:off x="7126122" y="4895748"/>
+            <a:ext cx="51206" cy="51206"/>
+          </a:xfrm>
+          <a:prstGeom prst="ellipse">
+            <a:avLst/>
+          </a:prstGeom>
+          <a:solidFill>
+            <a:srgbClr val="FFFFFF"/>
+          </a:solidFill>
+          <a:ln/>
+        </p:spPr>
+      </p:sp>
+      <p:sp>
+        <p:nvSpPr>
+          <p:cNvPr id="19" name="Text 16"/>
+          <p:cNvSpPr/>
+          <p:nvPr/>
+        </p:nvSpPr>
+        <p:spPr>
+          <a:xfrm>
+            <a:off x="7692644" y="3194101"/>
+            <a:ext cx="2094992" cy="632358"/>
+          </a:xfrm>
+          <a:prstGeom prst="roundRect">
+            <a:avLst>
+              <a:gd name="adj" fmla="val 13014"/>
+            </a:avLst>
+          </a:prstGeom>
+          <a:solidFill>
+            <a:srgbClr val="FFFFFF"/>
+          </a:solidFill>
+          <a:ln/>
+          <a:effectLst>
+            <a:outerShdw sx="100000" sy="100000" kx="0" ky="0" algn="bl" rotWithShape="0" blurRad="114300" dist="38100" dir="5400000">
+              <a:srgbClr val="8A8F98">
+                <a:alpha val="30000"/>
+              </a:srgbClr>
+            </a:outerShdw>
+          </a:effectLst>
+        </p:spPr>
+        <p:txBody>
+          <a:bodyPr wrap="square" lIns="889" tIns="889" rIns="889" bIns="889" rtlCol="0" anchor="ctr"/>
+          <a:lstStyle/>
+          <a:p>
+            <a:pPr algn="l" indent="0" marL="0">
+              <a:lnSpc>
+                <a:spcPct val="104000"/>
+              </a:lnSpc>
+              <a:buNone/>
+            </a:pPr>
+            <a:r>
+              <a:rPr lang="en-US" sz="1050" dirty="0">
+                <a:solidFill>
+                  <a:srgbClr val="1F2937"/>
+                </a:solidFill>
+                <a:latin typeface="Calibri" pitchFamily="34" charset="0"/>
+                <a:ea typeface="Calibri" pitchFamily="34" charset="-122"/>
+                <a:cs typeface="Calibri" pitchFamily="34" charset="-120"/>
+              </a:rPr>
+              <a:t>It ends in an action: export, or open the full analysis.</a:t>
+            </a:r>
+            <a:endParaRPr lang="en-US" sz="1050" dirty="0"/>
+          </a:p>
+        </p:txBody>
+      </p:sp>
     </p:spTree>
   </p:cSld>
   <p:clrMapOvr>
@@ -2747,7 +3211,7 @@
           <a:p>
             <a:pPr algn="l" indent="0" marL="0">
               <a:lnSpc>
-                <a:spcPct val="105000"/>
+                <a:spcPct val="104000"/>
               </a:lnSpc>
               <a:buNone/>
             </a:pPr>
@@ -2863,7 +3327,7 @@
           <a:p>
             <a:pPr algn="l" indent="0" marL="0">
               <a:lnSpc>
-                <a:spcPct val="105000"/>
+                <a:spcPct val="104000"/>
               </a:lnSpc>
               <a:buNone/>
             </a:pPr>
@@ -2979,7 +3443,7 @@
           <a:p>
             <a:pPr algn="l" indent="0" marL="0">
               <a:lnSpc>
-                <a:spcPct val="105000"/>
+                <a:spcPct val="104000"/>
               </a:lnSpc>
               <a:buNone/>
             </a:pPr>
@@ -3190,7 +3654,7 @@
           <a:p>
             <a:pPr algn="l" indent="0" marL="0">
               <a:lnSpc>
-                <a:spcPct val="105000"/>
+                <a:spcPct val="104000"/>
               </a:lnSpc>
               <a:buNone/>
             </a:pPr>
@@ -3306,7 +3770,7 @@
           <a:p>
             <a:pPr algn="l" indent="0" marL="0">
               <a:lnSpc>
-                <a:spcPct val="105000"/>
+                <a:spcPct val="104000"/>
               </a:lnSpc>
               <a:buNone/>
             </a:pPr>
@@ -3422,7 +3886,7 @@
           <a:p>
             <a:pPr algn="l" indent="0" marL="0">
               <a:lnSpc>
-                <a:spcPct val="105000"/>
+                <a:spcPct val="104000"/>
               </a:lnSpc>
               <a:buNone/>
             </a:pPr>
@@ -3633,7 +4097,7 @@
           <a:p>
             <a:pPr algn="l" indent="0" marL="0">
               <a:lnSpc>
-                <a:spcPct val="105000"/>
+                <a:spcPct val="104000"/>
               </a:lnSpc>
               <a:buNone/>
             </a:pPr>
@@ -3749,7 +4213,7 @@
           <a:p>
             <a:pPr algn="l" indent="0" marL="0">
               <a:lnSpc>
-                <a:spcPct val="105000"/>
+                <a:spcPct val="104000"/>
               </a:lnSpc>
               <a:buNone/>
             </a:pPr>
@@ -3865,7 +4329,7 @@
           <a:p>
             <a:pPr algn="ctr" indent="0" marL="0">
               <a:lnSpc>
-                <a:spcPct val="105000"/>
+                <a:spcPct val="104000"/>
               </a:lnSpc>
               <a:buNone/>
             </a:pPr>
@@ -3979,6 +4443,357 @@
           </a:prstGeom>
         </p:spPr>
       </p:pic>
+      <p:sp>
+        <p:nvSpPr>
+          <p:cNvPr id="4" name="Text 1"/>
+          <p:cNvSpPr/>
+          <p:nvPr/>
+        </p:nvSpPr>
+        <p:spPr>
+          <a:xfrm>
+            <a:off x="5536692" y="1821586"/>
+            <a:ext cx="4754880" cy="914400"/>
+          </a:xfrm>
+          <a:prstGeom prst="rect">
+            <a:avLst/>
+          </a:prstGeom>
+          <a:noFill/>
+          <a:ln/>
+        </p:spPr>
+        <p:txBody>
+          <a:bodyPr wrap="square" lIns="0" tIns="0" rIns="0" bIns="0" rtlCol="0" anchor="t"/>
+          <a:lstStyle/>
+          <a:p>
+            <a:pPr indent="0" marL="0">
+              <a:lnSpc>
+                <a:spcPct val="104000"/>
+              </a:lnSpc>
+              <a:spcAft>
+                <a:spcPts val="200"/>
+              </a:spcAft>
+              <a:buNone/>
+            </a:pPr>
+            <a:r>
+              <a:rPr lang="en-US" sz="1300" b="1" dirty="0">
+                <a:solidFill>
+                  <a:srgbClr val="1F2937"/>
+                </a:solidFill>
+                <a:latin typeface="Calibri" pitchFamily="34" charset="0"/>
+                <a:ea typeface="Calibri" pitchFamily="34" charset="-122"/>
+                <a:cs typeface="Calibri" pitchFamily="34" charset="-120"/>
+              </a:rPr>
+              <a:t>Depth 1 — the situation</a:t>
+            </a:r>
+            <a:endParaRPr lang="en-US" sz="1300" dirty="0"/>
+          </a:p>
+          <a:p>
+            <a:pPr indent="0" marL="0">
+              <a:lnSpc>
+                <a:spcPct val="104000"/>
+              </a:lnSpc>
+              <a:spcAft>
+                <a:spcPts val="200"/>
+              </a:spcAft>
+              <a:buNone/>
+            </a:pPr>
+            <a:r>
+              <a:rPr lang="en-US" sz="1150" i="1" dirty="0">
+                <a:solidFill>
+                  <a:srgbClr val="166534"/>
+                </a:solidFill>
+                <a:latin typeface="Calibri" pitchFamily="34" charset="0"/>
+                <a:ea typeface="Calibri" pitchFamily="34" charset="-122"/>
+                <a:cs typeface="Calibri" pitchFamily="34" charset="-120"/>
+              </a:rPr>
+              <a:t>“Is anything wrong today?”</a:t>
+            </a:r>
+            <a:endParaRPr lang="en-US" sz="1300" dirty="0"/>
+          </a:p>
+          <a:p>
+            <a:pPr indent="0" marL="0">
+              <a:lnSpc>
+                <a:spcPct val="104000"/>
+              </a:lnSpc>
+              <a:spcAft>
+                <a:spcPts val="200"/>
+              </a:spcAft>
+              <a:buNone/>
+            </a:pPr>
+            <a:r>
+              <a:rPr lang="en-US" sz="1000" dirty="0">
+                <a:solidFill>
+                  <a:srgbClr val="6B7280"/>
+                </a:solidFill>
+                <a:latin typeface="Calibri" pitchFamily="34" charset="0"/>
+                <a:ea typeface="Calibri" pitchFamily="34" charset="-122"/>
+                <a:cs typeface="Calibri" pitchFamily="34" charset="-120"/>
+              </a:rPr>
+              <a:t>A quick look, first thing in the morning.</a:t>
+            </a:r>
+            <a:endParaRPr lang="en-US" sz="1300" dirty="0"/>
+          </a:p>
+        </p:txBody>
+      </p:sp>
+      <p:sp>
+        <p:nvSpPr>
+          <p:cNvPr id="5" name="Text 2"/>
+          <p:cNvSpPr/>
+          <p:nvPr/>
+        </p:nvSpPr>
+        <p:spPr>
+          <a:xfrm>
+            <a:off x="5536692" y="3494938"/>
+            <a:ext cx="4754880" cy="914400"/>
+          </a:xfrm>
+          <a:prstGeom prst="rect">
+            <a:avLst/>
+          </a:prstGeom>
+          <a:noFill/>
+          <a:ln/>
+        </p:spPr>
+        <p:txBody>
+          <a:bodyPr wrap="square" lIns="0" tIns="0" rIns="0" bIns="0" rtlCol="0" anchor="t"/>
+          <a:lstStyle/>
+          <a:p>
+            <a:pPr indent="0" marL="0">
+              <a:lnSpc>
+                <a:spcPct val="104000"/>
+              </a:lnSpc>
+              <a:spcAft>
+                <a:spcPts val="200"/>
+              </a:spcAft>
+              <a:buNone/>
+            </a:pPr>
+            <a:r>
+              <a:rPr lang="en-US" sz="1300" b="1" dirty="0">
+                <a:solidFill>
+                  <a:srgbClr val="1F2937"/>
+                </a:solidFill>
+                <a:latin typeface="Calibri" pitchFamily="34" charset="0"/>
+                <a:ea typeface="Calibri" pitchFamily="34" charset="-122"/>
+                <a:cs typeface="Calibri" pitchFamily="34" charset="-120"/>
+              </a:rPr>
+              <a:t>Depth 2 — the question</a:t>
+            </a:r>
+            <a:endParaRPr lang="en-US" sz="1300" dirty="0"/>
+          </a:p>
+          <a:p>
+            <a:pPr indent="0" marL="0">
+              <a:lnSpc>
+                <a:spcPct val="104000"/>
+              </a:lnSpc>
+              <a:spcAft>
+                <a:spcPts val="200"/>
+              </a:spcAft>
+              <a:buNone/>
+            </a:pPr>
+            <a:r>
+              <a:rPr lang="en-US" sz="1150" i="1" dirty="0">
+                <a:solidFill>
+                  <a:srgbClr val="166534"/>
+                </a:solidFill>
+                <a:latin typeface="Calibri" pitchFamily="34" charset="0"/>
+                <a:ea typeface="Calibri" pitchFamily="34" charset="-122"/>
+                <a:cs typeface="Calibri" pitchFamily="34" charset="-120"/>
+              </a:rPr>
+              <a:t>“Which farms need attention?”</a:t>
+            </a:r>
+            <a:endParaRPr lang="en-US" sz="1300" dirty="0"/>
+          </a:p>
+          <a:p>
+            <a:pPr indent="0" marL="0">
+              <a:lnSpc>
+                <a:spcPct val="104000"/>
+              </a:lnSpc>
+              <a:spcAft>
+                <a:spcPts val="200"/>
+              </a:spcAft>
+              <a:buNone/>
+            </a:pPr>
+            <a:r>
+              <a:rPr lang="en-US" sz="1000" dirty="0">
+                <a:solidFill>
+                  <a:srgbClr val="6B7280"/>
+                </a:solidFill>
+                <a:latin typeface="Calibri" pitchFamily="34" charset="0"/>
+                <a:ea typeface="Calibri" pitchFamily="34" charset="-122"/>
+                <a:cs typeface="Calibri" pitchFamily="34" charset="-120"/>
+              </a:rPr>
+              <a:t>A ranked list to work through during the week.</a:t>
+            </a:r>
+            <a:endParaRPr lang="en-US" sz="1300" dirty="0"/>
+          </a:p>
+        </p:txBody>
+      </p:sp>
+      <p:sp>
+        <p:nvSpPr>
+          <p:cNvPr id="6" name="Text 3"/>
+          <p:cNvSpPr/>
+          <p:nvPr/>
+        </p:nvSpPr>
+        <p:spPr>
+          <a:xfrm>
+            <a:off x="5536692" y="5168290"/>
+            <a:ext cx="4754880" cy="914400"/>
+          </a:xfrm>
+          <a:prstGeom prst="rect">
+            <a:avLst/>
+          </a:prstGeom>
+          <a:noFill/>
+          <a:ln/>
+        </p:spPr>
+        <p:txBody>
+          <a:bodyPr wrap="square" lIns="0" tIns="0" rIns="0" bIns="0" rtlCol="0" anchor="t"/>
+          <a:lstStyle/>
+          <a:p>
+            <a:pPr indent="0" marL="0">
+              <a:lnSpc>
+                <a:spcPct val="104000"/>
+              </a:lnSpc>
+              <a:spcAft>
+                <a:spcPts val="200"/>
+              </a:spcAft>
+              <a:buNone/>
+            </a:pPr>
+            <a:r>
+              <a:rPr lang="en-US" sz="1300" b="1" dirty="0">
+                <a:solidFill>
+                  <a:srgbClr val="1F2937"/>
+                </a:solidFill>
+                <a:latin typeface="Calibri" pitchFamily="34" charset="0"/>
+                <a:ea typeface="Calibri" pitchFamily="34" charset="-122"/>
+                <a:cs typeface="Calibri" pitchFamily="34" charset="-120"/>
+              </a:rPr>
+              <a:t>Depth 3 — the farm</a:t>
+            </a:r>
+            <a:endParaRPr lang="en-US" sz="1300" dirty="0"/>
+          </a:p>
+          <a:p>
+            <a:pPr indent="0" marL="0">
+              <a:lnSpc>
+                <a:spcPct val="104000"/>
+              </a:lnSpc>
+              <a:spcAft>
+                <a:spcPts val="200"/>
+              </a:spcAft>
+              <a:buNone/>
+            </a:pPr>
+            <a:r>
+              <a:rPr lang="en-US" sz="1150" i="1" dirty="0">
+                <a:solidFill>
+                  <a:srgbClr val="166534"/>
+                </a:solidFill>
+                <a:latin typeface="Calibri" pitchFamily="34" charset="0"/>
+                <a:ea typeface="Calibri" pitchFamily="34" charset="-122"/>
+                <a:cs typeface="Calibri" pitchFamily="34" charset="-120"/>
+              </a:rPr>
+              <a:t>“What is happening on this farm?”</a:t>
+            </a:r>
+            <a:endParaRPr lang="en-US" sz="1300" dirty="0"/>
+          </a:p>
+          <a:p>
+            <a:pPr indent="0" marL="0">
+              <a:lnSpc>
+                <a:spcPct val="104000"/>
+              </a:lnSpc>
+              <a:spcAft>
+                <a:spcPts val="200"/>
+              </a:spcAft>
+              <a:buNone/>
+            </a:pPr>
+            <a:r>
+              <a:rPr lang="en-US" sz="1000" dirty="0">
+                <a:solidFill>
+                  <a:srgbClr val="6B7280"/>
+                </a:solidFill>
+                <a:latin typeface="Calibri" pitchFamily="34" charset="0"/>
+                <a:ea typeface="Calibri" pitchFamily="34" charset="-122"/>
+                <a:cs typeface="Calibri" pitchFamily="34" charset="-120"/>
+              </a:rPr>
+              <a:t>The full picture, before a visit or a call.</a:t>
+            </a:r>
+            <a:endParaRPr lang="en-US" sz="1300" dirty="0"/>
+          </a:p>
+        </p:txBody>
+      </p:sp>
+      <p:sp>
+        <p:nvSpPr>
+          <p:cNvPr id="7" name="Text 4"/>
+          <p:cNvSpPr/>
+          <p:nvPr/>
+        </p:nvSpPr>
+        <p:spPr>
+          <a:xfrm>
+            <a:off x="5276393" y="2856586"/>
+            <a:ext cx="1554480" cy="274320"/>
+          </a:xfrm>
+          <a:prstGeom prst="rect">
+            <a:avLst/>
+          </a:prstGeom>
+          <a:noFill/>
+          <a:ln/>
+        </p:spPr>
+        <p:txBody>
+          <a:bodyPr wrap="square" lIns="0" tIns="0" rIns="0" bIns="0" rtlCol="0" anchor="t"/>
+          <a:lstStyle/>
+          <a:p>
+            <a:pPr indent="0" marL="0">
+              <a:buNone/>
+            </a:pPr>
+            <a:r>
+              <a:rPr lang="en-US" sz="900" dirty="0">
+                <a:solidFill>
+                  <a:srgbClr val="6B7280"/>
+                </a:solidFill>
+                <a:latin typeface="Calibri" pitchFamily="34" charset="0"/>
+                <a:ea typeface="Calibri" pitchFamily="34" charset="-122"/>
+                <a:cs typeface="Calibri" pitchFamily="34" charset="-120"/>
+              </a:rPr>
+              <a:t>one level deeper</a:t>
+            </a:r>
+            <a:endParaRPr lang="en-US" sz="900" dirty="0"/>
+          </a:p>
+        </p:txBody>
+      </p:sp>
+      <p:sp>
+        <p:nvSpPr>
+          <p:cNvPr id="8" name="Text 5"/>
+          <p:cNvSpPr/>
+          <p:nvPr/>
+        </p:nvSpPr>
+        <p:spPr>
+          <a:xfrm>
+            <a:off x="5276393" y="4529938"/>
+            <a:ext cx="1554480" cy="274320"/>
+          </a:xfrm>
+          <a:prstGeom prst="rect">
+            <a:avLst/>
+          </a:prstGeom>
+          <a:noFill/>
+          <a:ln/>
+        </p:spPr>
+        <p:txBody>
+          <a:bodyPr wrap="square" lIns="0" tIns="0" rIns="0" bIns="0" rtlCol="0" anchor="t"/>
+          <a:lstStyle/>
+          <a:p>
+            <a:pPr indent="0" marL="0">
+              <a:buNone/>
+            </a:pPr>
+            <a:r>
+              <a:rPr lang="en-US" sz="900" dirty="0">
+                <a:solidFill>
+                  <a:srgbClr val="6B7280"/>
+                </a:solidFill>
+                <a:latin typeface="Calibri" pitchFamily="34" charset="0"/>
+                <a:ea typeface="Calibri" pitchFamily="34" charset="-122"/>
+                <a:cs typeface="Calibri" pitchFamily="34" charset="-120"/>
+              </a:rPr>
+              <a:t>one level deeper</a:t>
+            </a:r>
+            <a:endParaRPr lang="en-US" sz="900" dirty="0"/>
+          </a:p>
+        </p:txBody>
+      </p:sp>
     </p:spTree>
   </p:cSld>
   <p:clrMapOvr>
@@ -4264,6 +5079,470 @@
           </a:prstGeom>
         </p:spPr>
       </p:pic>
+      <p:sp>
+        <p:nvSpPr>
+          <p:cNvPr id="4" name="Shape 1"/>
+          <p:cNvSpPr/>
+          <p:nvPr/>
+        </p:nvSpPr>
+        <p:spPr>
+          <a:xfrm flipH="1">
+            <a:off x="3672637" y="2164131"/>
+            <a:ext cx="3651199" cy="255473"/>
+          </a:xfrm>
+          <a:prstGeom prst="line">
+            <a:avLst/>
+          </a:prstGeom>
+          <a:noFill/>
+          <a:ln w="12700">
+            <a:solidFill>
+              <a:srgbClr val="AEB4BC"/>
+            </a:solidFill>
+            <a:prstDash val="solid"/>
+          </a:ln>
+        </p:spPr>
+      </p:sp>
+      <p:sp>
+        <p:nvSpPr>
+          <p:cNvPr id="5" name="Shape 2"/>
+          <p:cNvSpPr/>
+          <p:nvPr/>
+        </p:nvSpPr>
+        <p:spPr>
+          <a:xfrm>
+            <a:off x="3608629" y="2355596"/>
+            <a:ext cx="128016" cy="128016"/>
+          </a:xfrm>
+          <a:prstGeom prst="ellipse">
+            <a:avLst/>
+          </a:prstGeom>
+          <a:solidFill>
+            <a:srgbClr val="166534"/>
+          </a:solidFill>
+          <a:ln/>
+        </p:spPr>
+      </p:sp>
+      <p:sp>
+        <p:nvSpPr>
+          <p:cNvPr id="6" name="Shape 3"/>
+          <p:cNvSpPr/>
+          <p:nvPr/>
+        </p:nvSpPr>
+        <p:spPr>
+          <a:xfrm>
+            <a:off x="3647034" y="2394001"/>
+            <a:ext cx="51206" cy="51206"/>
+          </a:xfrm>
+          <a:prstGeom prst="ellipse">
+            <a:avLst/>
+          </a:prstGeom>
+          <a:solidFill>
+            <a:srgbClr val="FFFFFF"/>
+          </a:solidFill>
+          <a:ln/>
+        </p:spPr>
+      </p:sp>
+      <p:sp>
+        <p:nvSpPr>
+          <p:cNvPr id="7" name="Text 4"/>
+          <p:cNvSpPr/>
+          <p:nvPr/>
+        </p:nvSpPr>
+        <p:spPr>
+          <a:xfrm>
+            <a:off x="7323836" y="1927860"/>
+            <a:ext cx="2156460" cy="472542"/>
+          </a:xfrm>
+          <a:prstGeom prst="roundRect">
+            <a:avLst>
+              <a:gd name="adj" fmla="val 17416"/>
+            </a:avLst>
+          </a:prstGeom>
+          <a:solidFill>
+            <a:srgbClr val="FFFFFF"/>
+          </a:solidFill>
+          <a:ln/>
+          <a:effectLst>
+            <a:outerShdw sx="100000" sy="100000" kx="0" ky="0" algn="bl" rotWithShape="0" blurRad="114300" dist="38100" dir="5400000">
+              <a:srgbClr val="8A8F98">
+                <a:alpha val="30000"/>
+              </a:srgbClr>
+            </a:outerShdw>
+          </a:effectLst>
+        </p:spPr>
+        <p:txBody>
+          <a:bodyPr wrap="square" lIns="889" tIns="889" rIns="889" bIns="889" rtlCol="0" anchor="ctr"/>
+          <a:lstStyle/>
+          <a:p>
+            <a:pPr algn="l" indent="0" marL="0">
+              <a:lnSpc>
+                <a:spcPct val="104000"/>
+              </a:lnSpc>
+              <a:buNone/>
+            </a:pPr>
+            <a:r>
+              <a:rPr lang="en-US" sz="1050" dirty="0">
+                <a:solidFill>
+                  <a:srgbClr val="1F2937"/>
+                </a:solidFill>
+                <a:latin typeface="Calibri" pitchFamily="34" charset="0"/>
+                <a:ea typeface="Calibri" pitchFamily="34" charset="-122"/>
+                <a:cs typeface="Calibri" pitchFamily="34" charset="-120"/>
+              </a:rPr>
+              <a:t>The region's numbers and the bands, in one panel.</a:t>
+            </a:r>
+            <a:endParaRPr lang="en-US" sz="1050" dirty="0"/>
+          </a:p>
+        </p:txBody>
+      </p:sp>
+      <p:sp>
+        <p:nvSpPr>
+          <p:cNvPr id="8" name="Shape 5"/>
+          <p:cNvSpPr/>
+          <p:nvPr/>
+        </p:nvSpPr>
+        <p:spPr>
+          <a:xfrm flipH="1">
+            <a:off x="5910072" y="2963215"/>
+            <a:ext cx="1413764" cy="194005"/>
+          </a:xfrm>
+          <a:prstGeom prst="line">
+            <a:avLst/>
+          </a:prstGeom>
+          <a:noFill/>
+          <a:ln w="12700">
+            <a:solidFill>
+              <a:srgbClr val="AEB4BC"/>
+            </a:solidFill>
+            <a:prstDash val="solid"/>
+          </a:ln>
+        </p:spPr>
+      </p:sp>
+      <p:sp>
+        <p:nvSpPr>
+          <p:cNvPr id="9" name="Shape 6"/>
+          <p:cNvSpPr/>
+          <p:nvPr/>
+        </p:nvSpPr>
+        <p:spPr>
+          <a:xfrm>
+            <a:off x="5846064" y="3093212"/>
+            <a:ext cx="128016" cy="128016"/>
+          </a:xfrm>
+          <a:prstGeom prst="ellipse">
+            <a:avLst/>
+          </a:prstGeom>
+          <a:solidFill>
+            <a:srgbClr val="166534"/>
+          </a:solidFill>
+          <a:ln/>
+        </p:spPr>
+      </p:sp>
+      <p:sp>
+        <p:nvSpPr>
+          <p:cNvPr id="10" name="Shape 7"/>
+          <p:cNvSpPr/>
+          <p:nvPr/>
+        </p:nvSpPr>
+        <p:spPr>
+          <a:xfrm>
+            <a:off x="5884469" y="3131617"/>
+            <a:ext cx="51206" cy="51206"/>
+          </a:xfrm>
+          <a:prstGeom prst="ellipse">
+            <a:avLst/>
+          </a:prstGeom>
+          <a:solidFill>
+            <a:srgbClr val="FFFFFF"/>
+          </a:solidFill>
+          <a:ln/>
+        </p:spPr>
+      </p:sp>
+      <p:sp>
+        <p:nvSpPr>
+          <p:cNvPr id="11" name="Text 8"/>
+          <p:cNvSpPr/>
+          <p:nvPr/>
+        </p:nvSpPr>
+        <p:spPr>
+          <a:xfrm>
+            <a:off x="7323836" y="2726944"/>
+            <a:ext cx="2217928" cy="472542"/>
+          </a:xfrm>
+          <a:prstGeom prst="roundRect">
+            <a:avLst>
+              <a:gd name="adj" fmla="val 17416"/>
+            </a:avLst>
+          </a:prstGeom>
+          <a:solidFill>
+            <a:srgbClr val="FFFFFF"/>
+          </a:solidFill>
+          <a:ln/>
+          <a:effectLst>
+            <a:outerShdw sx="100000" sy="100000" kx="0" ky="0" algn="bl" rotWithShape="0" blurRad="114300" dist="38100" dir="5400000">
+              <a:srgbClr val="8A8F98">
+                <a:alpha val="30000"/>
+              </a:srgbClr>
+            </a:outerShdw>
+          </a:effectLst>
+        </p:spPr>
+        <p:txBody>
+          <a:bodyPr wrap="square" lIns="889" tIns="889" rIns="889" bIns="889" rtlCol="0" anchor="ctr"/>
+          <a:lstStyle/>
+          <a:p>
+            <a:pPr algn="l" indent="0" marL="0">
+              <a:lnSpc>
+                <a:spcPct val="104000"/>
+              </a:lnSpc>
+              <a:buNone/>
+            </a:pPr>
+            <a:r>
+              <a:rPr lang="en-US" sz="1050" dirty="0">
+                <a:solidFill>
+                  <a:srgbClr val="1F2937"/>
+                </a:solidFill>
+                <a:latin typeface="Calibri" pitchFamily="34" charset="0"/>
+                <a:ea typeface="Calibri" pitchFamily="34" charset="-122"/>
+                <a:cs typeface="Calibri" pitchFamily="34" charset="-120"/>
+              </a:rPr>
+              <a:t>One fixed lens: overall health. Colour shows where the problems are.</a:t>
+            </a:r>
+            <a:endParaRPr lang="en-US" sz="1050" dirty="0"/>
+          </a:p>
+        </p:txBody>
+      </p:sp>
+      <p:sp>
+        <p:nvSpPr>
+          <p:cNvPr id="12" name="Shape 9"/>
+          <p:cNvSpPr/>
+          <p:nvPr/>
+        </p:nvSpPr>
+        <p:spPr>
+          <a:xfrm flipH="1">
+            <a:off x="3672637" y="3836060"/>
+            <a:ext cx="3651199" cy="556666"/>
+          </a:xfrm>
+          <a:prstGeom prst="line">
+            <a:avLst/>
+          </a:prstGeom>
+          <a:noFill/>
+          <a:ln w="12700">
+            <a:solidFill>
+              <a:srgbClr val="AEB4BC"/>
+            </a:solidFill>
+            <a:prstDash val="solid"/>
+          </a:ln>
+        </p:spPr>
+      </p:sp>
+      <p:sp>
+        <p:nvSpPr>
+          <p:cNvPr id="13" name="Shape 10"/>
+          <p:cNvSpPr/>
+          <p:nvPr/>
+        </p:nvSpPr>
+        <p:spPr>
+          <a:xfrm>
+            <a:off x="3608629" y="4328719"/>
+            <a:ext cx="128016" cy="128016"/>
+          </a:xfrm>
+          <a:prstGeom prst="ellipse">
+            <a:avLst/>
+          </a:prstGeom>
+          <a:solidFill>
+            <a:srgbClr val="166534"/>
+          </a:solidFill>
+          <a:ln/>
+        </p:spPr>
+      </p:sp>
+      <p:sp>
+        <p:nvSpPr>
+          <p:cNvPr id="14" name="Shape 11"/>
+          <p:cNvSpPr/>
+          <p:nvPr/>
+        </p:nvSpPr>
+        <p:spPr>
+          <a:xfrm>
+            <a:off x="3647034" y="4367124"/>
+            <a:ext cx="51206" cy="51206"/>
+          </a:xfrm>
+          <a:prstGeom prst="ellipse">
+            <a:avLst/>
+          </a:prstGeom>
+          <a:solidFill>
+            <a:srgbClr val="FFFFFF"/>
+          </a:solidFill>
+          <a:ln/>
+        </p:spPr>
+      </p:sp>
+      <p:sp>
+        <p:nvSpPr>
+          <p:cNvPr id="15" name="Text 12"/>
+          <p:cNvSpPr/>
+          <p:nvPr/>
+        </p:nvSpPr>
+        <p:spPr>
+          <a:xfrm>
+            <a:off x="7323836" y="3526028"/>
+            <a:ext cx="2340864" cy="620065"/>
+          </a:xfrm>
+          <a:prstGeom prst="roundRect">
+            <a:avLst>
+              <a:gd name="adj" fmla="val 13272"/>
+            </a:avLst>
+          </a:prstGeom>
+          <a:solidFill>
+            <a:srgbClr val="FFFFFF"/>
+          </a:solidFill>
+          <a:ln/>
+          <a:effectLst>
+            <a:outerShdw sx="100000" sy="100000" kx="0" ky="0" algn="bl" rotWithShape="0" blurRad="114300" dist="38100" dir="5400000">
+              <a:srgbClr val="8A8F98">
+                <a:alpha val="30000"/>
+              </a:srgbClr>
+            </a:outerShdw>
+          </a:effectLst>
+        </p:spPr>
+        <p:txBody>
+          <a:bodyPr wrap="square" lIns="889" tIns="889" rIns="889" bIns="889" rtlCol="0" anchor="ctr"/>
+          <a:lstStyle/>
+          <a:p>
+            <a:pPr algn="l" indent="0" marL="0">
+              <a:lnSpc>
+                <a:spcPct val="104000"/>
+              </a:lnSpc>
+              <a:buNone/>
+            </a:pPr>
+            <a:r>
+              <a:rPr lang="en-US" sz="1050" dirty="0">
+                <a:solidFill>
+                  <a:srgbClr val="1F2937"/>
+                </a:solidFill>
+                <a:latin typeface="Calibri" pitchFamily="34" charset="0"/>
+                <a:ea typeface="Calibri" pitchFamily="34" charset="-122"/>
+                <a:cs typeface="Calibri" pitchFamily="34" charset="-120"/>
+              </a:rPr>
+              <a:t>One filter, under the legend. Pick crops or trees and the whole page narrows.</a:t>
+            </a:r>
+            <a:endParaRPr lang="en-US" sz="1050" dirty="0"/>
+          </a:p>
+        </p:txBody>
+      </p:sp>
+      <p:sp>
+        <p:nvSpPr>
+          <p:cNvPr id="16" name="Shape 13"/>
+          <p:cNvSpPr/>
+          <p:nvPr/>
+        </p:nvSpPr>
+        <p:spPr>
+          <a:xfrm flipH="1" flipV="1">
+            <a:off x="4711446" y="4853737"/>
+            <a:ext cx="2612390" cy="14986"/>
+          </a:xfrm>
+          <a:prstGeom prst="line">
+            <a:avLst/>
+          </a:prstGeom>
+          <a:noFill/>
+          <a:ln w="12700">
+            <a:solidFill>
+              <a:srgbClr val="AEB4BC"/>
+            </a:solidFill>
+            <a:prstDash val="solid"/>
+          </a:ln>
+        </p:spPr>
+      </p:sp>
+      <p:sp>
+        <p:nvSpPr>
+          <p:cNvPr id="17" name="Shape 14"/>
+          <p:cNvSpPr/>
+          <p:nvPr/>
+        </p:nvSpPr>
+        <p:spPr>
+          <a:xfrm>
+            <a:off x="4647438" y="4789729"/>
+            <a:ext cx="128016" cy="128016"/>
+          </a:xfrm>
+          <a:prstGeom prst="ellipse">
+            <a:avLst/>
+          </a:prstGeom>
+          <a:solidFill>
+            <a:srgbClr val="166534"/>
+          </a:solidFill>
+          <a:ln/>
+        </p:spPr>
+      </p:sp>
+      <p:sp>
+        <p:nvSpPr>
+          <p:cNvPr id="18" name="Shape 15"/>
+          <p:cNvSpPr/>
+          <p:nvPr/>
+        </p:nvSpPr>
+        <p:spPr>
+          <a:xfrm>
+            <a:off x="4685843" y="4828134"/>
+            <a:ext cx="51206" cy="51206"/>
+          </a:xfrm>
+          <a:prstGeom prst="ellipse">
+            <a:avLst/>
+          </a:prstGeom>
+          <a:solidFill>
+            <a:srgbClr val="FFFFFF"/>
+          </a:solidFill>
+          <a:ln/>
+        </p:spPr>
+      </p:sp>
+      <p:sp>
+        <p:nvSpPr>
+          <p:cNvPr id="19" name="Text 16"/>
+          <p:cNvSpPr/>
+          <p:nvPr/>
+        </p:nvSpPr>
+        <p:spPr>
+          <a:xfrm>
+            <a:off x="7323836" y="4632452"/>
+            <a:ext cx="2217928" cy="472542"/>
+          </a:xfrm>
+          <a:prstGeom prst="roundRect">
+            <a:avLst>
+              <a:gd name="adj" fmla="val 17416"/>
+            </a:avLst>
+          </a:prstGeom>
+          <a:solidFill>
+            <a:srgbClr val="FFFFFF"/>
+          </a:solidFill>
+          <a:ln/>
+          <a:effectLst>
+            <a:outerShdw sx="100000" sy="100000" kx="0" ky="0" algn="bl" rotWithShape="0" blurRad="114300" dist="38100" dir="5400000">
+              <a:srgbClr val="8A8F98">
+                <a:alpha val="30000"/>
+              </a:srgbClr>
+            </a:outerShdw>
+          </a:effectLst>
+        </p:spPr>
+        <p:txBody>
+          <a:bodyPr wrap="square" lIns="889" tIns="889" rIns="889" bIns="889" rtlCol="0" anchor="ctr"/>
+          <a:lstStyle/>
+          <a:p>
+            <a:pPr algn="l" indent="0" marL="0">
+              <a:lnSpc>
+                <a:spcPct val="104000"/>
+              </a:lnSpc>
+              <a:buNone/>
+            </a:pPr>
+            <a:r>
+              <a:rPr lang="en-US" sz="1050" dirty="0">
+                <a:solidFill>
+                  <a:srgbClr val="1F2937"/>
+                </a:solidFill>
+                <a:latin typeface="Calibri" pitchFamily="34" charset="0"/>
+                <a:ea typeface="Calibri" pitchFamily="34" charset="-122"/>
+                <a:cs typeface="Calibri" pitchFamily="34" charset="-120"/>
+              </a:rPr>
+              <a:t>Six cards, one status word each. Each opens its module.</a:t>
+            </a:r>
+            <a:endParaRPr lang="en-US" sz="1050" dirty="0"/>
+          </a:p>
+        </p:txBody>
+      </p:sp>
     </p:spTree>
   </p:cSld>
   <p:clrMapOvr>
@@ -4456,7 +5735,7 @@
           <a:p>
             <a:pPr algn="l" indent="0" marL="0">
               <a:lnSpc>
-                <a:spcPct val="105000"/>
+                <a:spcPct val="104000"/>
               </a:lnSpc>
               <a:buNone/>
             </a:pPr>
@@ -4572,7 +5851,7 @@
           <a:p>
             <a:pPr algn="l" indent="0" marL="0">
               <a:lnSpc>
-                <a:spcPct val="105000"/>
+                <a:spcPct val="104000"/>
               </a:lnSpc>
               <a:buNone/>
             </a:pPr>
@@ -4688,7 +5967,7 @@
           <a:p>
             <a:pPr algn="ctr" indent="0" marL="0">
               <a:lnSpc>
-                <a:spcPct val="105000"/>
+                <a:spcPct val="104000"/>
               </a:lnSpc>
               <a:buNone/>
             </a:pPr>
@@ -4802,6 +6081,702 @@
           </a:prstGeom>
         </p:spPr>
       </p:pic>
+      <p:sp>
+        <p:nvSpPr>
+          <p:cNvPr id="4" name="Shape 1"/>
+          <p:cNvSpPr/>
+          <p:nvPr/>
+        </p:nvSpPr>
+        <p:spPr>
+          <a:xfrm flipH="1">
+            <a:off x="6819798" y="2096516"/>
+            <a:ext cx="504038" cy="132537"/>
+          </a:xfrm>
+          <a:prstGeom prst="line">
+            <a:avLst/>
+          </a:prstGeom>
+          <a:noFill/>
+          <a:ln w="12700">
+            <a:solidFill>
+              <a:srgbClr val="AEB4BC"/>
+            </a:solidFill>
+            <a:prstDash val="solid"/>
+          </a:ln>
+        </p:spPr>
+      </p:sp>
+      <p:sp>
+        <p:nvSpPr>
+          <p:cNvPr id="5" name="Shape 2"/>
+          <p:cNvSpPr/>
+          <p:nvPr/>
+        </p:nvSpPr>
+        <p:spPr>
+          <a:xfrm>
+            <a:off x="6755790" y="2165045"/>
+            <a:ext cx="128016" cy="128016"/>
+          </a:xfrm>
+          <a:prstGeom prst="ellipse">
+            <a:avLst/>
+          </a:prstGeom>
+          <a:solidFill>
+            <a:srgbClr val="166534"/>
+          </a:solidFill>
+          <a:ln/>
+        </p:spPr>
+      </p:sp>
+      <p:sp>
+        <p:nvSpPr>
+          <p:cNvPr id="6" name="Shape 3"/>
+          <p:cNvSpPr/>
+          <p:nvPr/>
+        </p:nvSpPr>
+        <p:spPr>
+          <a:xfrm>
+            <a:off x="6794195" y="2203450"/>
+            <a:ext cx="51206" cy="51206"/>
+          </a:xfrm>
+          <a:prstGeom prst="ellipse">
+            <a:avLst/>
+          </a:prstGeom>
+          <a:solidFill>
+            <a:srgbClr val="FFFFFF"/>
+          </a:solidFill>
+          <a:ln/>
+        </p:spPr>
+      </p:sp>
+      <p:sp>
+        <p:nvSpPr>
+          <p:cNvPr id="7" name="Text 4"/>
+          <p:cNvSpPr/>
+          <p:nvPr/>
+        </p:nvSpPr>
+        <p:spPr>
+          <a:xfrm>
+            <a:off x="7323836" y="1921713"/>
+            <a:ext cx="1972056" cy="349606"/>
+          </a:xfrm>
+          <a:prstGeom prst="roundRect">
+            <a:avLst>
+              <a:gd name="adj" fmla="val 23540"/>
+            </a:avLst>
+          </a:prstGeom>
+          <a:solidFill>
+            <a:srgbClr val="FFFFFF"/>
+          </a:solidFill>
+          <a:ln/>
+          <a:effectLst>
+            <a:outerShdw sx="100000" sy="100000" kx="0" ky="0" algn="bl" rotWithShape="0" blurRad="114300" dist="38100" dir="5400000">
+              <a:srgbClr val="8A8F98">
+                <a:alpha val="30000"/>
+              </a:srgbClr>
+            </a:outerShdw>
+          </a:effectLst>
+        </p:spPr>
+        <p:txBody>
+          <a:bodyPr wrap="square" lIns="889" tIns="889" rIns="889" bIns="889" rtlCol="0" anchor="ctr"/>
+          <a:lstStyle/>
+          <a:p>
+            <a:pPr algn="l" indent="0" marL="0">
+              <a:lnSpc>
+                <a:spcPct val="104000"/>
+              </a:lnSpc>
+              <a:buNone/>
+            </a:pPr>
+            <a:r>
+              <a:rPr lang="en-US" sz="1050" dirty="0">
+                <a:solidFill>
+                  <a:srgbClr val="1F2937"/>
+                </a:solidFill>
+                <a:latin typeface="Calibri" pitchFamily="34" charset="0"/>
+                <a:ea typeface="Calibri" pitchFamily="34" charset="-122"/>
+                <a:cs typeface="Calibri" pitchFamily="34" charset="-120"/>
+              </a:rPr>
+              <a:t>The numbers for this question.</a:t>
+            </a:r>
+            <a:endParaRPr lang="en-US" sz="1050" dirty="0"/>
+          </a:p>
+        </p:txBody>
+      </p:sp>
+      <p:sp>
+        <p:nvSpPr>
+          <p:cNvPr id="8" name="Shape 5"/>
+          <p:cNvSpPr/>
+          <p:nvPr/>
+        </p:nvSpPr>
+        <p:spPr>
+          <a:xfrm flipH="1">
+            <a:off x="4348785" y="2827985"/>
+            <a:ext cx="2975051" cy="206299"/>
+          </a:xfrm>
+          <a:prstGeom prst="line">
+            <a:avLst/>
+          </a:prstGeom>
+          <a:noFill/>
+          <a:ln w="12700">
+            <a:solidFill>
+              <a:srgbClr val="AEB4BC"/>
+            </a:solidFill>
+            <a:prstDash val="solid"/>
+          </a:ln>
+        </p:spPr>
+      </p:sp>
+      <p:sp>
+        <p:nvSpPr>
+          <p:cNvPr id="9" name="Shape 6"/>
+          <p:cNvSpPr/>
+          <p:nvPr/>
+        </p:nvSpPr>
+        <p:spPr>
+          <a:xfrm>
+            <a:off x="4284777" y="2970276"/>
+            <a:ext cx="128016" cy="128016"/>
+          </a:xfrm>
+          <a:prstGeom prst="ellipse">
+            <a:avLst/>
+          </a:prstGeom>
+          <a:solidFill>
+            <a:srgbClr val="166534"/>
+          </a:solidFill>
+          <a:ln/>
+        </p:spPr>
+      </p:sp>
+      <p:sp>
+        <p:nvSpPr>
+          <p:cNvPr id="10" name="Shape 7"/>
+          <p:cNvSpPr/>
+          <p:nvPr/>
+        </p:nvSpPr>
+        <p:spPr>
+          <a:xfrm>
+            <a:off x="4323182" y="3008681"/>
+            <a:ext cx="51206" cy="51206"/>
+          </a:xfrm>
+          <a:prstGeom prst="ellipse">
+            <a:avLst/>
+          </a:prstGeom>
+          <a:solidFill>
+            <a:srgbClr val="FFFFFF"/>
+          </a:solidFill>
+          <a:ln/>
+        </p:spPr>
+      </p:sp>
+      <p:sp>
+        <p:nvSpPr>
+          <p:cNvPr id="11" name="Text 8"/>
+          <p:cNvSpPr/>
+          <p:nvPr/>
+        </p:nvSpPr>
+        <p:spPr>
+          <a:xfrm>
+            <a:off x="7323836" y="2585568"/>
+            <a:ext cx="1972056" cy="484835"/>
+          </a:xfrm>
+          <a:prstGeom prst="roundRect">
+            <a:avLst>
+              <a:gd name="adj" fmla="val 16974"/>
+            </a:avLst>
+          </a:prstGeom>
+          <a:solidFill>
+            <a:srgbClr val="FFFFFF"/>
+          </a:solidFill>
+          <a:ln/>
+          <a:effectLst>
+            <a:outerShdw sx="100000" sy="100000" kx="0" ky="0" algn="bl" rotWithShape="0" blurRad="114300" dist="38100" dir="5400000">
+              <a:srgbClr val="8A8F98">
+                <a:alpha val="30000"/>
+              </a:srgbClr>
+            </a:outerShdw>
+          </a:effectLst>
+        </p:spPr>
+        <p:txBody>
+          <a:bodyPr wrap="square" lIns="889" tIns="889" rIns="889" bIns="889" rtlCol="0" anchor="ctr"/>
+          <a:lstStyle/>
+          <a:p>
+            <a:pPr algn="l" indent="0" marL="0">
+              <a:lnSpc>
+                <a:spcPct val="104000"/>
+              </a:lnSpc>
+              <a:buNone/>
+            </a:pPr>
+            <a:r>
+              <a:rPr lang="en-US" sz="1050" dirty="0">
+                <a:solidFill>
+                  <a:srgbClr val="1F2937"/>
+                </a:solidFill>
+                <a:latin typeface="Calibri" pitchFamily="34" charset="0"/>
+                <a:ea typeface="Calibri" pitchFamily="34" charset="-122"/>
+                <a:cs typeface="Calibri" pitchFamily="34" charset="-120"/>
+              </a:rPr>
+              <a:t>One legend. The same colours everywhere.</a:t>
+            </a:r>
+            <a:endParaRPr lang="en-US" sz="1050" dirty="0"/>
+          </a:p>
+        </p:txBody>
+      </p:sp>
+      <p:sp>
+        <p:nvSpPr>
+          <p:cNvPr id="12" name="Shape 9"/>
+          <p:cNvSpPr/>
+          <p:nvPr/>
+        </p:nvSpPr>
+        <p:spPr>
+          <a:xfrm flipH="1">
+            <a:off x="4348785" y="3577895"/>
+            <a:ext cx="2975051" cy="304648"/>
+          </a:xfrm>
+          <a:prstGeom prst="line">
+            <a:avLst/>
+          </a:prstGeom>
+          <a:noFill/>
+          <a:ln w="12700">
+            <a:solidFill>
+              <a:srgbClr val="AEB4BC"/>
+            </a:solidFill>
+            <a:prstDash val="solid"/>
+          </a:ln>
+        </p:spPr>
+      </p:sp>
+      <p:sp>
+        <p:nvSpPr>
+          <p:cNvPr id="13" name="Shape 10"/>
+          <p:cNvSpPr/>
+          <p:nvPr/>
+        </p:nvSpPr>
+        <p:spPr>
+          <a:xfrm>
+            <a:off x="4284777" y="3818534"/>
+            <a:ext cx="128016" cy="128016"/>
+          </a:xfrm>
+          <a:prstGeom prst="ellipse">
+            <a:avLst/>
+          </a:prstGeom>
+          <a:solidFill>
+            <a:srgbClr val="166534"/>
+          </a:solidFill>
+          <a:ln/>
+        </p:spPr>
+      </p:sp>
+      <p:sp>
+        <p:nvSpPr>
+          <p:cNvPr id="14" name="Shape 11"/>
+          <p:cNvSpPr/>
+          <p:nvPr/>
+        </p:nvSpPr>
+        <p:spPr>
+          <a:xfrm>
+            <a:off x="4323182" y="3856939"/>
+            <a:ext cx="51206" cy="51206"/>
+          </a:xfrm>
+          <a:prstGeom prst="ellipse">
+            <a:avLst/>
+          </a:prstGeom>
+          <a:solidFill>
+            <a:srgbClr val="FFFFFF"/>
+          </a:solidFill>
+          <a:ln/>
+        </p:spPr>
+      </p:sp>
+      <p:sp>
+        <p:nvSpPr>
+          <p:cNvPr id="15" name="Text 12"/>
+          <p:cNvSpPr/>
+          <p:nvPr/>
+        </p:nvSpPr>
+        <p:spPr>
+          <a:xfrm>
+            <a:off x="7323836" y="3261716"/>
+            <a:ext cx="2094992" cy="632358"/>
+          </a:xfrm>
+          <a:prstGeom prst="roundRect">
+            <a:avLst>
+              <a:gd name="adj" fmla="val 13014"/>
+            </a:avLst>
+          </a:prstGeom>
+          <a:solidFill>
+            <a:srgbClr val="FFFFFF"/>
+          </a:solidFill>
+          <a:ln/>
+          <a:effectLst>
+            <a:outerShdw sx="100000" sy="100000" kx="0" ky="0" algn="bl" rotWithShape="0" blurRad="114300" dist="38100" dir="5400000">
+              <a:srgbClr val="8A8F98">
+                <a:alpha val="30000"/>
+              </a:srgbClr>
+            </a:outerShdw>
+          </a:effectLst>
+        </p:spPr>
+        <p:txBody>
+          <a:bodyPr wrap="square" lIns="889" tIns="889" rIns="889" bIns="889" rtlCol="0" anchor="ctr"/>
+          <a:lstStyle/>
+          <a:p>
+            <a:pPr algn="l" indent="0" marL="0">
+              <a:lnSpc>
+                <a:spcPct val="104000"/>
+              </a:lnSpc>
+              <a:buNone/>
+            </a:pPr>
+            <a:r>
+              <a:rPr lang="en-US" sz="1050" dirty="0">
+                <a:solidFill>
+                  <a:srgbClr val="1F2937"/>
+                </a:solidFill>
+                <a:latin typeface="Calibri" pitchFamily="34" charset="0"/>
+                <a:ea typeface="Calibri" pitchFamily="34" charset="-122"/>
+                <a:cs typeface="Calibri" pitchFamily="34" charset="-120"/>
+              </a:rPr>
+              <a:t>Tick a crop or a tree type. The map and every number narrow together.</a:t>
+            </a:r>
+            <a:endParaRPr lang="en-US" sz="1050" dirty="0"/>
+          </a:p>
+        </p:txBody>
+      </p:sp>
+      <p:sp>
+        <p:nvSpPr>
+          <p:cNvPr id="16" name="Shape 13"/>
+          <p:cNvSpPr/>
+          <p:nvPr/>
+        </p:nvSpPr>
+        <p:spPr>
+          <a:xfrm flipH="1" flipV="1">
+            <a:off x="6340348" y="4214470"/>
+            <a:ext cx="983488" cy="39573"/>
+          </a:xfrm>
+          <a:prstGeom prst="line">
+            <a:avLst/>
+          </a:prstGeom>
+          <a:noFill/>
+          <a:ln w="12700">
+            <a:solidFill>
+              <a:srgbClr val="AEB4BC"/>
+            </a:solidFill>
+            <a:prstDash val="solid"/>
+          </a:ln>
+        </p:spPr>
+      </p:sp>
+      <p:sp>
+        <p:nvSpPr>
+          <p:cNvPr id="17" name="Shape 14"/>
+          <p:cNvSpPr/>
+          <p:nvPr/>
+        </p:nvSpPr>
+        <p:spPr>
+          <a:xfrm>
+            <a:off x="6276340" y="4150462"/>
+            <a:ext cx="128016" cy="128016"/>
+          </a:xfrm>
+          <a:prstGeom prst="ellipse">
+            <a:avLst/>
+          </a:prstGeom>
+          <a:solidFill>
+            <a:srgbClr val="166534"/>
+          </a:solidFill>
+          <a:ln/>
+        </p:spPr>
+      </p:sp>
+      <p:sp>
+        <p:nvSpPr>
+          <p:cNvPr id="18" name="Shape 15"/>
+          <p:cNvSpPr/>
+          <p:nvPr/>
+        </p:nvSpPr>
+        <p:spPr>
+          <a:xfrm>
+            <a:off x="6314745" y="4188866"/>
+            <a:ext cx="51206" cy="51206"/>
+          </a:xfrm>
+          <a:prstGeom prst="ellipse">
+            <a:avLst/>
+          </a:prstGeom>
+          <a:solidFill>
+            <a:srgbClr val="FFFFFF"/>
+          </a:solidFill>
+          <a:ln/>
+        </p:spPr>
+      </p:sp>
+      <p:sp>
+        <p:nvSpPr>
+          <p:cNvPr id="19" name="Text 16"/>
+          <p:cNvSpPr/>
+          <p:nvPr/>
+        </p:nvSpPr>
+        <p:spPr>
+          <a:xfrm>
+            <a:off x="7323836" y="4011625"/>
+            <a:ext cx="1849120" cy="484835"/>
+          </a:xfrm>
+          <a:prstGeom prst="roundRect">
+            <a:avLst>
+              <a:gd name="adj" fmla="val 16974"/>
+            </a:avLst>
+          </a:prstGeom>
+          <a:solidFill>
+            <a:srgbClr val="FFFFFF"/>
+          </a:solidFill>
+          <a:ln/>
+          <a:effectLst>
+            <a:outerShdw sx="100000" sy="100000" kx="0" ky="0" algn="bl" rotWithShape="0" blurRad="114300" dist="38100" dir="5400000">
+              <a:srgbClr val="8A8F98">
+                <a:alpha val="30000"/>
+              </a:srgbClr>
+            </a:outerShdw>
+          </a:effectLst>
+        </p:spPr>
+        <p:txBody>
+          <a:bodyPr wrap="square" lIns="889" tIns="889" rIns="889" bIns="889" rtlCol="0" anchor="ctr"/>
+          <a:lstStyle/>
+          <a:p>
+            <a:pPr algn="l" indent="0" marL="0">
+              <a:lnSpc>
+                <a:spcPct val="104000"/>
+              </a:lnSpc>
+              <a:buNone/>
+            </a:pPr>
+            <a:r>
+              <a:rPr lang="en-US" sz="1050" dirty="0">
+                <a:solidFill>
+                  <a:srgbClr val="1F2937"/>
+                </a:solidFill>
+                <a:latin typeface="Calibri" pitchFamily="34" charset="0"/>
+                <a:ea typeface="Calibri" pitchFamily="34" charset="-122"/>
+                <a:cs typeface="Calibri" pitchFamily="34" charset="-120"/>
+              </a:rPr>
+              <a:t>The map, coloured by this question only.</a:t>
+            </a:r>
+            <a:endParaRPr lang="en-US" sz="1050" dirty="0"/>
+          </a:p>
+        </p:txBody>
+      </p:sp>
+      <p:sp>
+        <p:nvSpPr>
+          <p:cNvPr id="20" name="Shape 17"/>
+          <p:cNvSpPr/>
+          <p:nvPr/>
+        </p:nvSpPr>
+        <p:spPr>
+          <a:xfrm flipH="1" flipV="1">
+            <a:off x="6733743" y="4779975"/>
+            <a:ext cx="590093" cy="113335"/>
+          </a:xfrm>
+          <a:prstGeom prst="line">
+            <a:avLst/>
+          </a:prstGeom>
+          <a:noFill/>
+          <a:ln w="12700">
+            <a:solidFill>
+              <a:srgbClr val="AEB4BC"/>
+            </a:solidFill>
+            <a:prstDash val="solid"/>
+          </a:ln>
+        </p:spPr>
+      </p:sp>
+      <p:sp>
+        <p:nvSpPr>
+          <p:cNvPr id="21" name="Shape 18"/>
+          <p:cNvSpPr/>
+          <p:nvPr/>
+        </p:nvSpPr>
+        <p:spPr>
+          <a:xfrm>
+            <a:off x="6669735" y="4715967"/>
+            <a:ext cx="128016" cy="128016"/>
+          </a:xfrm>
+          <a:prstGeom prst="ellipse">
+            <a:avLst/>
+          </a:prstGeom>
+          <a:solidFill>
+            <a:srgbClr val="166534"/>
+          </a:solidFill>
+          <a:ln/>
+        </p:spPr>
+      </p:sp>
+      <p:sp>
+        <p:nvSpPr>
+          <p:cNvPr id="22" name="Shape 19"/>
+          <p:cNvSpPr/>
+          <p:nvPr/>
+        </p:nvSpPr>
+        <p:spPr>
+          <a:xfrm>
+            <a:off x="6708140" y="4754372"/>
+            <a:ext cx="51206" cy="51206"/>
+          </a:xfrm>
+          <a:prstGeom prst="ellipse">
+            <a:avLst/>
+          </a:prstGeom>
+          <a:solidFill>
+            <a:srgbClr val="FFFFFF"/>
+          </a:solidFill>
+          <a:ln/>
+        </p:spPr>
+      </p:sp>
+      <p:sp>
+        <p:nvSpPr>
+          <p:cNvPr id="23" name="Text 20"/>
+          <p:cNvSpPr/>
+          <p:nvPr/>
+        </p:nvSpPr>
+        <p:spPr>
+          <a:xfrm>
+            <a:off x="7323836" y="4650892"/>
+            <a:ext cx="1849120" cy="484835"/>
+          </a:xfrm>
+          <a:prstGeom prst="roundRect">
+            <a:avLst>
+              <a:gd name="adj" fmla="val 16974"/>
+            </a:avLst>
+          </a:prstGeom>
+          <a:solidFill>
+            <a:srgbClr val="FFFFFF"/>
+          </a:solidFill>
+          <a:ln/>
+          <a:effectLst>
+            <a:outerShdw sx="100000" sy="100000" kx="0" ky="0" algn="bl" rotWithShape="0" blurRad="114300" dist="38100" dir="5400000">
+              <a:srgbClr val="8A8F98">
+                <a:alpha val="30000"/>
+              </a:srgbClr>
+            </a:outerShdw>
+          </a:effectLst>
+        </p:spPr>
+        <p:txBody>
+          <a:bodyPr wrap="square" lIns="889" tIns="889" rIns="889" bIns="889" rtlCol="0" anchor="ctr"/>
+          <a:lstStyle/>
+          <a:p>
+            <a:pPr algn="l" indent="0" marL="0">
+              <a:lnSpc>
+                <a:spcPct val="104000"/>
+              </a:lnSpc>
+              <a:buNone/>
+            </a:pPr>
+            <a:r>
+              <a:rPr lang="en-US" sz="1050" dirty="0">
+                <a:solidFill>
+                  <a:srgbClr val="1F2937"/>
+                </a:solidFill>
+                <a:latin typeface="Calibri" pitchFamily="34" charset="0"/>
+                <a:ea typeface="Calibri" pitchFamily="34" charset="-122"/>
+                <a:cs typeface="Calibri" pitchFamily="34" charset="-120"/>
+              </a:rPr>
+              <a:t>The list can leave the app as a file.</a:t>
+            </a:r>
+            <a:endParaRPr lang="en-US" sz="1050" dirty="0"/>
+          </a:p>
+        </p:txBody>
+      </p:sp>
+      <p:sp>
+        <p:nvSpPr>
+          <p:cNvPr id="24" name="Shape 21"/>
+          <p:cNvSpPr/>
+          <p:nvPr/>
+        </p:nvSpPr>
+        <p:spPr>
+          <a:xfrm flipH="1" flipV="1">
+            <a:off x="6832092" y="5222545"/>
+            <a:ext cx="491744" cy="334620"/>
+          </a:xfrm>
+          <a:prstGeom prst="line">
+            <a:avLst/>
+          </a:prstGeom>
+          <a:noFill/>
+          <a:ln w="12700">
+            <a:solidFill>
+              <a:srgbClr val="AEB4BC"/>
+            </a:solidFill>
+            <a:prstDash val="solid"/>
+          </a:ln>
+        </p:spPr>
+      </p:sp>
+      <p:sp>
+        <p:nvSpPr>
+          <p:cNvPr id="25" name="Shape 22"/>
+          <p:cNvSpPr/>
+          <p:nvPr/>
+        </p:nvSpPr>
+        <p:spPr>
+          <a:xfrm>
+            <a:off x="6768084" y="5158537"/>
+            <a:ext cx="128016" cy="128016"/>
+          </a:xfrm>
+          <a:prstGeom prst="ellipse">
+            <a:avLst/>
+          </a:prstGeom>
+          <a:solidFill>
+            <a:srgbClr val="166534"/>
+          </a:solidFill>
+          <a:ln/>
+        </p:spPr>
+      </p:sp>
+      <p:sp>
+        <p:nvSpPr>
+          <p:cNvPr id="26" name="Shape 23"/>
+          <p:cNvSpPr/>
+          <p:nvPr/>
+        </p:nvSpPr>
+        <p:spPr>
+          <a:xfrm>
+            <a:off x="6806489" y="5196942"/>
+            <a:ext cx="51206" cy="51206"/>
+          </a:xfrm>
+          <a:prstGeom prst="ellipse">
+            <a:avLst/>
+          </a:prstGeom>
+          <a:solidFill>
+            <a:srgbClr val="FFFFFF"/>
+          </a:solidFill>
+          <a:ln/>
+        </p:spPr>
+      </p:sp>
+      <p:sp>
+        <p:nvSpPr>
+          <p:cNvPr id="27" name="Text 24"/>
+          <p:cNvSpPr/>
+          <p:nvPr/>
+        </p:nvSpPr>
+        <p:spPr>
+          <a:xfrm>
+            <a:off x="7323836" y="5382362"/>
+            <a:ext cx="1972056" cy="349606"/>
+          </a:xfrm>
+          <a:prstGeom prst="roundRect">
+            <a:avLst>
+              <a:gd name="adj" fmla="val 23540"/>
+            </a:avLst>
+          </a:prstGeom>
+          <a:solidFill>
+            <a:srgbClr val="FFFFFF"/>
+          </a:solidFill>
+          <a:ln/>
+          <a:effectLst>
+            <a:outerShdw sx="100000" sy="100000" kx="0" ky="0" algn="bl" rotWithShape="0" blurRad="114300" dist="38100" dir="5400000">
+              <a:srgbClr val="8A8F98">
+                <a:alpha val="30000"/>
+              </a:srgbClr>
+            </a:outerShdw>
+          </a:effectLst>
+        </p:spPr>
+        <p:txBody>
+          <a:bodyPr wrap="square" lIns="889" tIns="889" rIns="889" bIns="889" rtlCol="0" anchor="ctr"/>
+          <a:lstStyle/>
+          <a:p>
+            <a:pPr algn="l" indent="0" marL="0">
+              <a:lnSpc>
+                <a:spcPct val="104000"/>
+              </a:lnSpc>
+              <a:buNone/>
+            </a:pPr>
+            <a:r>
+              <a:rPr lang="en-US" sz="1050" dirty="0">
+                <a:solidFill>
+                  <a:srgbClr val="1F2937"/>
+                </a:solidFill>
+                <a:latin typeface="Calibri" pitchFamily="34" charset="0"/>
+                <a:ea typeface="Calibri" pitchFamily="34" charset="-122"/>
+                <a:cs typeface="Calibri" pitchFamily="34" charset="-120"/>
+              </a:rPr>
+              <a:t>Farms ranked worst first.</a:t>
+            </a:r>
+            <a:endParaRPr lang="en-US" sz="1050" dirty="0"/>
+          </a:p>
+        </p:txBody>
+      </p:sp>
     </p:spTree>
   </p:cSld>
   <p:clrMapOvr>

</xml_diff>